<commit_message>
ppt 수정, routing 코드 추가
</commit_message>
<xml_diff>
--- a/material/4_WEB/04_react.pptx
+++ b/material/4_WEB/04_react.pptx
@@ -258,7 +258,7 @@
           <a:p>
             <a:fld id="{2EF3F159-7250-4DD4-91C2-13B35D56E1AF}" type="datetimeFigureOut">
               <a:rPr lang="ko-KR" altLang="en-US" smtClean="0"/>
-              <a:t>2026-01-06</a:t>
+              <a:t>2026-02-04</a:t>
             </a:fld>
             <a:endParaRPr lang="ko-KR" altLang="en-US"/>
           </a:p>
@@ -9486,7 +9486,7 @@
           <a:p>
             <a:fld id="{442BEE3F-2E9A-4FD8-8B8A-8619F3E161C0}" type="datetime1">
               <a:rPr lang="ko-KR" altLang="en-US" smtClean="0"/>
-              <a:t>2026-01-06</a:t>
+              <a:t>2026-02-04</a:t>
             </a:fld>
             <a:endParaRPr lang="ko-KR" altLang="en-US"/>
           </a:p>
@@ -9773,7 +9773,7 @@
           <a:p>
             <a:fld id="{0F78D9C4-20C1-4B15-A116-16DC77AD9A1E}" type="datetime1">
               <a:rPr lang="ko-KR" altLang="en-US" smtClean="0"/>
-              <a:t>2026-01-06</a:t>
+              <a:t>2026-02-04</a:t>
             </a:fld>
             <a:endParaRPr lang="ko-KR" altLang="en-US"/>
           </a:p>
@@ -9949,7 +9949,7 @@
             <a:fld id="{7F5E23C3-0E3D-4E4E-8486-D7FB4C073DC1}" type="datetime1">
               <a:rPr lang="ko-KR" altLang="en-US" smtClean="0"/>
               <a:pPr/>
-              <a:t>2026-01-06</a:t>
+              <a:t>2026-02-04</a:t>
             </a:fld>
             <a:endParaRPr lang="ko-KR" altLang="en-US" dirty="0"/>
           </a:p>
@@ -10064,7 +10064,7 @@
           <a:p>
             <a:fld id="{0E19CB95-6D28-40F1-9DA3-1BAC5D4B5B4F}" type="datetime6">
               <a:rPr lang="ko-KR" altLang="en-US" smtClean="0"/>
-              <a:t>2026년 1월</a:t>
+              <a:t>2026년 2월</a:t>
             </a:fld>
             <a:endParaRPr lang="ko-KR" altLang="en-US"/>
           </a:p>
@@ -10486,7 +10486,7 @@
             <a:fld id="{7F5E23C3-0E3D-4E4E-8486-D7FB4C073DC1}" type="datetime1">
               <a:rPr lang="ko-KR" altLang="en-US" smtClean="0"/>
               <a:pPr/>
-              <a:t>2026-01-06</a:t>
+              <a:t>2026-02-04</a:t>
             </a:fld>
             <a:endParaRPr lang="ko-KR" altLang="en-US" dirty="0"/>
           </a:p>
@@ -11587,7 +11587,7 @@
           <a:p>
             <a:fld id="{383A7BEF-B73A-49F5-82B0-918E780DEC4B}" type="datetime6">
               <a:rPr lang="ko-KR" altLang="en-US" smtClean="0"/>
-              <a:t>2026년 1월</a:t>
+              <a:t>2026년 2월</a:t>
             </a:fld>
             <a:endParaRPr lang="ko-KR" altLang="en-US" dirty="0"/>
           </a:p>
@@ -11773,7 +11773,7 @@
           <a:p>
             <a:fld id="{3C9CE3CE-253F-4F9D-BA15-C226C8D8501E}" type="datetime6">
               <a:rPr lang="ko-KR" altLang="en-US" smtClean="0"/>
-              <a:t>2026년 1월</a:t>
+              <a:t>2026년 2월</a:t>
             </a:fld>
             <a:endParaRPr lang="ko-KR" altLang="en-US"/>
           </a:p>
@@ -11964,7 +11964,7 @@
           <a:p>
             <a:fld id="{F46385CA-27A9-4DEA-8849-A362F4ECB08E}" type="datetime6">
               <a:rPr lang="ko-KR" altLang="en-US" smtClean="0"/>
-              <a:t>2026년 1월</a:t>
+              <a:t>2026년 2월</a:t>
             </a:fld>
             <a:endParaRPr lang="ko-KR" altLang="en-US"/>
           </a:p>
@@ -12189,7 +12189,7 @@
           <a:p>
             <a:fld id="{FACD5DEE-25A5-4339-9AC2-7BA35671899D}" type="datetime6">
               <a:rPr lang="ko-KR" altLang="en-US" smtClean="0"/>
-              <a:t>2026년 1월</a:t>
+              <a:t>2026년 2월</a:t>
             </a:fld>
             <a:endParaRPr lang="ko-KR" altLang="en-US"/>
           </a:p>
@@ -12477,7 +12477,7 @@
           <a:p>
             <a:fld id="{CEDCD4D2-499C-4900-92C8-E32DFC679E3E}" type="datetime6">
               <a:rPr lang="ko-KR" altLang="en-US" smtClean="0"/>
-              <a:t>2026년 1월</a:t>
+              <a:t>2026년 2월</a:t>
             </a:fld>
             <a:endParaRPr lang="ko-KR" altLang="en-US"/>
           </a:p>
@@ -12760,7 +12760,7 @@
           <a:p>
             <a:fld id="{345E3EB5-E321-4CB7-8431-D125BB957E9D}" type="datetime6">
               <a:rPr lang="ko-KR" altLang="en-US" smtClean="0"/>
-              <a:t>2026년 1월</a:t>
+              <a:t>2026년 2월</a:t>
             </a:fld>
             <a:endParaRPr lang="ko-KR" altLang="en-US"/>
           </a:p>
@@ -12972,7 +12972,7 @@
           <a:p>
             <a:fld id="{6A18317B-3DB3-4419-8714-D2B1AFCB8599}" type="datetime6">
               <a:rPr lang="ko-KR" altLang="en-US" smtClean="0"/>
-              <a:t>2026년 1월</a:t>
+              <a:t>2026년 2월</a:t>
             </a:fld>
             <a:endParaRPr lang="ko-KR" altLang="en-US"/>
           </a:p>
@@ -13406,7 +13406,7 @@
           <a:p>
             <a:fld id="{6A18317B-3DB3-4419-8714-D2B1AFCB8599}" type="datetime6">
               <a:rPr lang="ko-KR" altLang="en-US" smtClean="0"/>
-              <a:t>2026년 1월</a:t>
+              <a:t>2026년 2월</a:t>
             </a:fld>
             <a:endParaRPr lang="ko-KR" altLang="en-US"/>
           </a:p>
@@ -13894,7 +13894,7 @@
           <a:p>
             <a:fld id="{DF29B623-B367-4165-8C2F-DFDEC75DE620}" type="datetime6">
               <a:rPr lang="ko-KR" altLang="en-US" smtClean="0"/>
-              <a:t>2026년 1월</a:t>
+              <a:t>2026년 2월</a:t>
             </a:fld>
             <a:endParaRPr lang="ko-KR" altLang="en-US"/>
           </a:p>
@@ -14104,7 +14104,7 @@
           <a:p>
             <a:fld id="{F9404E03-9351-4410-87CA-D059FFF49069}" type="datetime6">
               <a:rPr lang="ko-KR" altLang="en-US" smtClean="0"/>
-              <a:t>2026년 1월</a:t>
+              <a:t>2026년 2월</a:t>
             </a:fld>
             <a:endParaRPr lang="ko-KR" altLang="en-US"/>
           </a:p>
@@ -14254,7 +14254,7 @@
           <a:p>
             <a:fld id="{0E19CB95-6D28-40F1-9DA3-1BAC5D4B5B4F}" type="datetime6">
               <a:rPr lang="ko-KR" altLang="en-US" smtClean="0"/>
-              <a:t>2026년 1월</a:t>
+              <a:t>2026년 2월</a:t>
             </a:fld>
             <a:endParaRPr lang="ko-KR" altLang="en-US"/>
           </a:p>
@@ -14370,7 +14370,7 @@
           <a:p>
             <a:fld id="{0E19CB95-6D28-40F1-9DA3-1BAC5D4B5B4F}" type="datetime6">
               <a:rPr lang="ko-KR" altLang="en-US" smtClean="0"/>
-              <a:t>2026년 1월</a:t>
+              <a:t>2026년 2월</a:t>
             </a:fld>
             <a:endParaRPr lang="ko-KR" altLang="en-US"/>
           </a:p>
@@ -14715,7 +14715,7 @@
           <a:p>
             <a:fld id="{3C9CE3CE-253F-4F9D-BA15-C226C8D8501E}" type="datetime6">
               <a:rPr lang="ko-KR" altLang="en-US" smtClean="0"/>
-              <a:t>2026년 1월</a:t>
+              <a:t>2026년 2월</a:t>
             </a:fld>
             <a:endParaRPr lang="ko-KR" altLang="en-US"/>
           </a:p>
@@ -14917,7 +14917,7 @@
           <a:p>
             <a:fld id="{3C9CE3CE-253F-4F9D-BA15-C226C8D8501E}" type="datetime6">
               <a:rPr lang="ko-KR" altLang="en-US" smtClean="0"/>
-              <a:t>2026년 1월</a:t>
+              <a:t>2026년 2월</a:t>
             </a:fld>
             <a:endParaRPr lang="ko-KR" altLang="en-US"/>
           </a:p>
@@ -15134,7 +15134,7 @@
           <a:p>
             <a:fld id="{3C9CE3CE-253F-4F9D-BA15-C226C8D8501E}" type="datetime6">
               <a:rPr lang="ko-KR" altLang="en-US" smtClean="0"/>
-              <a:t>2026년 1월</a:t>
+              <a:t>2026년 2월</a:t>
             </a:fld>
             <a:endParaRPr lang="ko-KR" altLang="en-US"/>
           </a:p>
@@ -15293,7 +15293,7 @@
           <a:p>
             <a:fld id="{0E19CB95-6D28-40F1-9DA3-1BAC5D4B5B4F}" type="datetime6">
               <a:rPr lang="ko-KR" altLang="en-US" smtClean="0"/>
-              <a:t>2026년 1월</a:t>
+              <a:t>2026년 2월</a:t>
             </a:fld>
             <a:endParaRPr lang="ko-KR" altLang="en-US"/>
           </a:p>
@@ -15557,7 +15557,7 @@
           <a:p>
             <a:fld id="{3C9CE3CE-253F-4F9D-BA15-C226C8D8501E}" type="datetime6">
               <a:rPr lang="ko-KR" altLang="en-US" smtClean="0"/>
-              <a:t>2026년 1월</a:t>
+              <a:t>2026년 2월</a:t>
             </a:fld>
             <a:endParaRPr lang="ko-KR" altLang="en-US"/>
           </a:p>
@@ -15768,7 +15768,7 @@
           <a:p>
             <a:fld id="{3C9CE3CE-253F-4F9D-BA15-C226C8D8501E}" type="datetime6">
               <a:rPr lang="ko-KR" altLang="en-US" smtClean="0"/>
-              <a:t>2026년 1월</a:t>
+              <a:t>2026년 2월</a:t>
             </a:fld>
             <a:endParaRPr lang="ko-KR" altLang="en-US"/>
           </a:p>
@@ -16151,7 +16151,7 @@
           <a:p>
             <a:fld id="{3C9CE3CE-253F-4F9D-BA15-C226C8D8501E}" type="datetime6">
               <a:rPr lang="ko-KR" altLang="en-US" smtClean="0"/>
-              <a:t>2026년 1월</a:t>
+              <a:t>2026년 2월</a:t>
             </a:fld>
             <a:endParaRPr lang="ko-KR" altLang="en-US"/>
           </a:p>
@@ -16602,7 +16602,7 @@
           <a:p>
             <a:fld id="{0E19CB95-6D28-40F1-9DA3-1BAC5D4B5B4F}" type="datetime6">
               <a:rPr lang="ko-KR" altLang="en-US" smtClean="0"/>
-              <a:t>2026년 1월</a:t>
+              <a:t>2026년 2월</a:t>
             </a:fld>
             <a:endParaRPr lang="ko-KR" altLang="en-US"/>
           </a:p>
@@ -16873,7 +16873,7 @@
           <a:p>
             <a:fld id="{8E0AE71B-4077-4B0C-A21C-DB8409E582EB}" type="datetime6">
               <a:rPr lang="ko-KR" altLang="en-US" smtClean="0"/>
-              <a:t>2026년 1월</a:t>
+              <a:t>2026년 2월</a:t>
             </a:fld>
             <a:endParaRPr lang="ko-KR" altLang="en-US"/>
           </a:p>
@@ -18151,7 +18151,7 @@
           <a:p>
             <a:fld id="{6468698F-A099-4459-96DD-C5B99D5CE837}" type="datetime6">
               <a:rPr lang="ko-KR" altLang="en-US" smtClean="0"/>
-              <a:t>2026년 1월</a:t>
+              <a:t>2026년 2월</a:t>
             </a:fld>
             <a:endParaRPr lang="ko-KR" altLang="en-US"/>
           </a:p>
@@ -18439,7 +18439,7 @@
           <a:p>
             <a:fld id="{3C9CE3CE-253F-4F9D-BA15-C226C8D8501E}" type="datetime6">
               <a:rPr lang="ko-KR" altLang="en-US" smtClean="0"/>
-              <a:t>2026년 1월</a:t>
+              <a:t>2026년 2월</a:t>
             </a:fld>
             <a:endParaRPr lang="ko-KR" altLang="en-US"/>
           </a:p>
@@ -19963,7 +19963,7 @@
           <a:p>
             <a:fld id="{0E19CB95-6D28-40F1-9DA3-1BAC5D4B5B4F}" type="datetime6">
               <a:rPr lang="ko-KR" altLang="en-US" smtClean="0"/>
-              <a:t>2026년 1월</a:t>
+              <a:t>2026년 2월</a:t>
             </a:fld>
             <a:endParaRPr lang="ko-KR" altLang="en-US"/>
           </a:p>
@@ -20164,7 +20164,7 @@
           <a:p>
             <a:fld id="{3C9CE3CE-253F-4F9D-BA15-C226C8D8501E}" type="datetime6">
               <a:rPr lang="ko-KR" altLang="en-US" smtClean="0"/>
-              <a:t>2026년 1월</a:t>
+              <a:t>2026년 2월</a:t>
             </a:fld>
             <a:endParaRPr lang="ko-KR" altLang="en-US"/>
           </a:p>
@@ -23185,7 +23185,7 @@
           <a:p>
             <a:fld id="{0C68695F-ED15-4181-BC24-4818008DEB4A}" type="datetime6">
               <a:rPr lang="ko-KR" altLang="en-US" smtClean="0"/>
-              <a:t>2026년 1월</a:t>
+              <a:t>2026년 2월</a:t>
             </a:fld>
             <a:endParaRPr lang="ko-KR" altLang="en-US"/>
           </a:p>
@@ -31153,7 +31153,7 @@
           <a:p>
             <a:fld id="{6E4A776D-1119-47AB-8A89-B6C229E43FDB}" type="datetime6">
               <a:rPr lang="ko-KR" altLang="en-US" smtClean="0"/>
-              <a:t>2026년 1월</a:t>
+              <a:t>2026년 2월</a:t>
             </a:fld>
             <a:endParaRPr lang="ko-KR" altLang="en-US"/>
           </a:p>
@@ -31307,7 +31307,7 @@
           <a:p>
             <a:fld id="{F7A0D294-60EA-4DAA-90A4-E86E9A5EB9AE}" type="datetime6">
               <a:rPr lang="ko-KR" altLang="en-US" smtClean="0"/>
-              <a:t>2026년 1월</a:t>
+              <a:t>2026년 2월</a:t>
             </a:fld>
             <a:endParaRPr lang="ko-KR" altLang="en-US"/>
           </a:p>
@@ -31624,7 +31624,7 @@
           <a:p>
             <a:fld id="{91D2DBD1-6134-4975-8CE7-24ED1E9282F4}" type="datetime6">
               <a:rPr lang="ko-KR" altLang="en-US" smtClean="0"/>
-              <a:t>2026년 1월</a:t>
+              <a:t>2026년 2월</a:t>
             </a:fld>
             <a:endParaRPr lang="ko-KR" altLang="en-US"/>
           </a:p>
@@ -32642,7 +32642,7 @@
           <a:p>
             <a:fld id="{679F1434-6E25-475C-8377-59FE6BAECDE6}" type="datetime6">
               <a:rPr lang="ko-KR" altLang="en-US" smtClean="0"/>
-              <a:t>2026년 1월</a:t>
+              <a:t>2026년 2월</a:t>
             </a:fld>
             <a:endParaRPr lang="ko-KR" altLang="en-US"/>
           </a:p>
@@ -32866,7 +32866,7 @@
           <a:p>
             <a:fld id="{4E92E807-52C8-4999-93D3-9678270AD8FA}" type="datetime6">
               <a:rPr lang="ko-KR" altLang="en-US" smtClean="0"/>
-              <a:t>2026년 1월</a:t>
+              <a:t>2026년 2월</a:t>
             </a:fld>
             <a:endParaRPr lang="ko-KR" altLang="en-US"/>
           </a:p>
@@ -32931,12 +32931,476 @@
           </a:prstGeom>
         </p:spPr>
       </p:pic>
+      <p:sp>
+        <p:nvSpPr>
+          <p:cNvPr id="7" name="내용 개체 틀 2">
+            <a:extLst>
+              <a:ext uri="{FF2B5EF4-FFF2-40B4-BE49-F238E27FC236}">
+                <a16:creationId xmlns:a16="http://schemas.microsoft.com/office/drawing/2014/main" id="{24A70FDD-59B7-03AC-60AC-4AAEEEF9E093}"/>
+              </a:ext>
+            </a:extLst>
+          </p:cNvPr>
+          <p:cNvSpPr txBox="1">
+            <a:spLocks/>
+          </p:cNvSpPr>
+          <p:nvPr/>
+        </p:nvSpPr>
+        <p:spPr>
+          <a:xfrm>
+            <a:off x="283840" y="3180090"/>
+            <a:ext cx="3867614" cy="437819"/>
+          </a:xfrm>
+          <a:prstGeom prst="rect">
+            <a:avLst/>
+          </a:prstGeom>
+        </p:spPr>
+        <p:txBody>
+          <a:bodyPr vert="horz" lIns="91440" tIns="45720" rIns="91440" bIns="45720" rtlCol="0">
+            <a:normAutofit/>
+          </a:bodyPr>
+          <a:lstStyle>
+            <a:lvl1pPr marL="228600" indent="-228600" algn="l" defTabSz="914400" rtl="0" eaLnBrk="1" latinLnBrk="1" hangingPunct="1">
+              <a:lnSpc>
+                <a:spcPct val="120000"/>
+              </a:lnSpc>
+              <a:spcBef>
+                <a:spcPts val="1000"/>
+              </a:spcBef>
+              <a:buFont typeface="Arial" panose="020B0604020202020204" pitchFamily="34" charset="0"/>
+              <a:buChar char="•"/>
+              <a:defRPr sz="2800" kern="1200">
+                <a:solidFill>
+                  <a:schemeClr val="tx1"/>
+                </a:solidFill>
+                <a:latin typeface="+mn-lt"/>
+                <a:ea typeface="+mn-ea"/>
+                <a:cs typeface="+mn-cs"/>
+              </a:defRPr>
+            </a:lvl1pPr>
+            <a:lvl2pPr marL="685800" indent="-228600" algn="l" defTabSz="914400" rtl="0" eaLnBrk="1" latinLnBrk="1" hangingPunct="1">
+              <a:lnSpc>
+                <a:spcPct val="120000"/>
+              </a:lnSpc>
+              <a:spcBef>
+                <a:spcPts val="500"/>
+              </a:spcBef>
+              <a:buFont typeface="Arial" panose="020B0604020202020204" pitchFamily="34" charset="0"/>
+              <a:buChar char="•"/>
+              <a:defRPr sz="2400" kern="1200">
+                <a:solidFill>
+                  <a:schemeClr val="tx1"/>
+                </a:solidFill>
+                <a:latin typeface="+mn-lt"/>
+                <a:ea typeface="+mn-ea"/>
+                <a:cs typeface="+mn-cs"/>
+              </a:defRPr>
+            </a:lvl2pPr>
+            <a:lvl3pPr marL="1143000" indent="-228600" algn="l" defTabSz="914400" rtl="0" eaLnBrk="1" latinLnBrk="1" hangingPunct="1">
+              <a:lnSpc>
+                <a:spcPct val="120000"/>
+              </a:lnSpc>
+              <a:spcBef>
+                <a:spcPts val="500"/>
+              </a:spcBef>
+              <a:buFont typeface="Arial" panose="020B0604020202020204" pitchFamily="34" charset="0"/>
+              <a:buChar char="•"/>
+              <a:defRPr sz="2000" kern="1200">
+                <a:solidFill>
+                  <a:schemeClr val="tx1"/>
+                </a:solidFill>
+                <a:latin typeface="+mn-lt"/>
+                <a:ea typeface="+mn-ea"/>
+                <a:cs typeface="+mn-cs"/>
+              </a:defRPr>
+            </a:lvl3pPr>
+            <a:lvl4pPr marL="1600200" indent="-228600" algn="l" defTabSz="914400" rtl="0" eaLnBrk="1" latinLnBrk="1" hangingPunct="1">
+              <a:lnSpc>
+                <a:spcPct val="120000"/>
+              </a:lnSpc>
+              <a:spcBef>
+                <a:spcPts val="500"/>
+              </a:spcBef>
+              <a:buFont typeface="Arial" panose="020B0604020202020204" pitchFamily="34" charset="0"/>
+              <a:buChar char="•"/>
+              <a:defRPr sz="1800" kern="1200">
+                <a:solidFill>
+                  <a:schemeClr val="tx1"/>
+                </a:solidFill>
+                <a:latin typeface="+mn-lt"/>
+                <a:ea typeface="+mn-ea"/>
+                <a:cs typeface="+mn-cs"/>
+              </a:defRPr>
+            </a:lvl4pPr>
+            <a:lvl5pPr marL="2057400" indent="-228600" algn="l" defTabSz="914400" rtl="0" eaLnBrk="1" latinLnBrk="1" hangingPunct="1">
+              <a:lnSpc>
+                <a:spcPct val="120000"/>
+              </a:lnSpc>
+              <a:spcBef>
+                <a:spcPts val="500"/>
+              </a:spcBef>
+              <a:buFont typeface="Arial" panose="020B0604020202020204" pitchFamily="34" charset="0"/>
+              <a:buChar char="•"/>
+              <a:defRPr sz="1800" kern="1200">
+                <a:solidFill>
+                  <a:schemeClr val="tx1"/>
+                </a:solidFill>
+                <a:latin typeface="+mn-lt"/>
+                <a:ea typeface="+mn-ea"/>
+                <a:cs typeface="+mn-cs"/>
+              </a:defRPr>
+            </a:lvl5pPr>
+            <a:lvl6pPr marL="2514600" indent="-228600" algn="l" defTabSz="914400" rtl="0" eaLnBrk="1" latinLnBrk="1" hangingPunct="1">
+              <a:lnSpc>
+                <a:spcPct val="90000"/>
+              </a:lnSpc>
+              <a:spcBef>
+                <a:spcPts val="500"/>
+              </a:spcBef>
+              <a:buFont typeface="Arial" panose="020B0604020202020204" pitchFamily="34" charset="0"/>
+              <a:buChar char="•"/>
+              <a:defRPr sz="1800" kern="1200">
+                <a:solidFill>
+                  <a:schemeClr val="tx1"/>
+                </a:solidFill>
+                <a:latin typeface="+mn-lt"/>
+                <a:ea typeface="+mn-ea"/>
+                <a:cs typeface="+mn-cs"/>
+              </a:defRPr>
+            </a:lvl6pPr>
+            <a:lvl7pPr marL="2971800" indent="-228600" algn="l" defTabSz="914400" rtl="0" eaLnBrk="1" latinLnBrk="1" hangingPunct="1">
+              <a:lnSpc>
+                <a:spcPct val="90000"/>
+              </a:lnSpc>
+              <a:spcBef>
+                <a:spcPts val="500"/>
+              </a:spcBef>
+              <a:buFont typeface="Arial" panose="020B0604020202020204" pitchFamily="34" charset="0"/>
+              <a:buChar char="•"/>
+              <a:defRPr sz="1800" kern="1200">
+                <a:solidFill>
+                  <a:schemeClr val="tx1"/>
+                </a:solidFill>
+                <a:latin typeface="+mn-lt"/>
+                <a:ea typeface="+mn-ea"/>
+                <a:cs typeface="+mn-cs"/>
+              </a:defRPr>
+            </a:lvl7pPr>
+            <a:lvl8pPr marL="3429000" indent="-228600" algn="l" defTabSz="914400" rtl="0" eaLnBrk="1" latinLnBrk="1" hangingPunct="1">
+              <a:lnSpc>
+                <a:spcPct val="90000"/>
+              </a:lnSpc>
+              <a:spcBef>
+                <a:spcPts val="500"/>
+              </a:spcBef>
+              <a:buFont typeface="Arial" panose="020B0604020202020204" pitchFamily="34" charset="0"/>
+              <a:buChar char="•"/>
+              <a:defRPr sz="1800" kern="1200">
+                <a:solidFill>
+                  <a:schemeClr val="tx1"/>
+                </a:solidFill>
+                <a:latin typeface="+mn-lt"/>
+                <a:ea typeface="+mn-ea"/>
+                <a:cs typeface="+mn-cs"/>
+              </a:defRPr>
+            </a:lvl8pPr>
+            <a:lvl9pPr marL="3886200" indent="-228600" algn="l" defTabSz="914400" rtl="0" eaLnBrk="1" latinLnBrk="1" hangingPunct="1">
+              <a:lnSpc>
+                <a:spcPct val="90000"/>
+              </a:lnSpc>
+              <a:spcBef>
+                <a:spcPts val="500"/>
+              </a:spcBef>
+              <a:buFont typeface="Arial" panose="020B0604020202020204" pitchFamily="34" charset="0"/>
+              <a:buChar char="•"/>
+              <a:defRPr sz="1800" kern="1200">
+                <a:solidFill>
+                  <a:schemeClr val="tx1"/>
+                </a:solidFill>
+                <a:latin typeface="+mn-lt"/>
+                <a:ea typeface="+mn-ea"/>
+                <a:cs typeface="+mn-cs"/>
+              </a:defRPr>
+            </a:lvl9pPr>
+          </a:lstStyle>
+          <a:p>
+            <a:pPr marL="0" indent="0">
+              <a:buFont typeface="Arial" panose="020B0604020202020204" pitchFamily="34" charset="0"/>
+              <a:buNone/>
+            </a:pPr>
+            <a:r>
+              <a:rPr lang="en-US" altLang="ko-KR" sz="1800" b="1" dirty="0">
+                <a:solidFill>
+                  <a:schemeClr val="bg1">
+                    <a:lumMod val="50000"/>
+                  </a:schemeClr>
+                </a:solidFill>
+                <a:latin typeface="Pretendard Medium" panose="02000603000000020004" pitchFamily="50" charset="-127"/>
+                <a:ea typeface="Pretendard Medium" panose="02000603000000020004" pitchFamily="50" charset="-127"/>
+              </a:rPr>
+              <a:t>*</a:t>
+            </a:r>
+            <a:r>
+              <a:rPr lang="ko-KR" altLang="en-US" sz="1800" b="1" dirty="0">
+                <a:solidFill>
+                  <a:schemeClr val="bg1">
+                    <a:lumMod val="50000"/>
+                  </a:schemeClr>
+                </a:solidFill>
+                <a:latin typeface="Pretendard Medium" panose="02000603000000020004" pitchFamily="50" charset="-127"/>
+                <a:ea typeface="Pretendard Medium" panose="02000603000000020004" pitchFamily="50" charset="-127"/>
+              </a:rPr>
+              <a:t> 부모 컴포넌트</a:t>
+            </a:r>
+            <a:endParaRPr lang="en-US" altLang="ko-KR" sz="1800" b="1" dirty="0">
+              <a:solidFill>
+                <a:schemeClr val="bg1">
+                  <a:lumMod val="50000"/>
+                </a:schemeClr>
+              </a:solidFill>
+              <a:latin typeface="Pretendard Medium" panose="02000603000000020004" pitchFamily="50" charset="-127"/>
+              <a:ea typeface="Pretendard Medium" panose="02000603000000020004" pitchFamily="50" charset="-127"/>
+            </a:endParaRPr>
+          </a:p>
+        </p:txBody>
+      </p:sp>
+      <p:sp>
+        <p:nvSpPr>
+          <p:cNvPr id="9" name="내용 개체 틀 2">
+            <a:extLst>
+              <a:ext uri="{FF2B5EF4-FFF2-40B4-BE49-F238E27FC236}">
+                <a16:creationId xmlns:a16="http://schemas.microsoft.com/office/drawing/2014/main" id="{4FF724C0-6D72-23E7-5BB6-6E2A64B863CA}"/>
+              </a:ext>
+            </a:extLst>
+          </p:cNvPr>
+          <p:cNvSpPr txBox="1">
+            <a:spLocks/>
+          </p:cNvSpPr>
+          <p:nvPr/>
+        </p:nvSpPr>
+        <p:spPr>
+          <a:xfrm>
+            <a:off x="971184" y="4372090"/>
+            <a:ext cx="3867614" cy="437819"/>
+          </a:xfrm>
+          <a:prstGeom prst="rect">
+            <a:avLst/>
+          </a:prstGeom>
+        </p:spPr>
+        <p:txBody>
+          <a:bodyPr vert="horz" lIns="91440" tIns="45720" rIns="91440" bIns="45720" rtlCol="0">
+            <a:normAutofit/>
+          </a:bodyPr>
+          <a:lstStyle>
+            <a:lvl1pPr marL="228600" indent="-228600" algn="l" defTabSz="914400" rtl="0" eaLnBrk="1" latinLnBrk="1" hangingPunct="1">
+              <a:lnSpc>
+                <a:spcPct val="120000"/>
+              </a:lnSpc>
+              <a:spcBef>
+                <a:spcPts val="1000"/>
+              </a:spcBef>
+              <a:buFont typeface="Arial" panose="020B0604020202020204" pitchFamily="34" charset="0"/>
+              <a:buChar char="•"/>
+              <a:defRPr sz="2800" kern="1200">
+                <a:solidFill>
+                  <a:schemeClr val="tx1"/>
+                </a:solidFill>
+                <a:latin typeface="+mn-lt"/>
+                <a:ea typeface="+mn-ea"/>
+                <a:cs typeface="+mn-cs"/>
+              </a:defRPr>
+            </a:lvl1pPr>
+            <a:lvl2pPr marL="685800" indent="-228600" algn="l" defTabSz="914400" rtl="0" eaLnBrk="1" latinLnBrk="1" hangingPunct="1">
+              <a:lnSpc>
+                <a:spcPct val="120000"/>
+              </a:lnSpc>
+              <a:spcBef>
+                <a:spcPts val="500"/>
+              </a:spcBef>
+              <a:buFont typeface="Arial" panose="020B0604020202020204" pitchFamily="34" charset="0"/>
+              <a:buChar char="•"/>
+              <a:defRPr sz="2400" kern="1200">
+                <a:solidFill>
+                  <a:schemeClr val="tx1"/>
+                </a:solidFill>
+                <a:latin typeface="+mn-lt"/>
+                <a:ea typeface="+mn-ea"/>
+                <a:cs typeface="+mn-cs"/>
+              </a:defRPr>
+            </a:lvl2pPr>
+            <a:lvl3pPr marL="1143000" indent="-228600" algn="l" defTabSz="914400" rtl="0" eaLnBrk="1" latinLnBrk="1" hangingPunct="1">
+              <a:lnSpc>
+                <a:spcPct val="120000"/>
+              </a:lnSpc>
+              <a:spcBef>
+                <a:spcPts val="500"/>
+              </a:spcBef>
+              <a:buFont typeface="Arial" panose="020B0604020202020204" pitchFamily="34" charset="0"/>
+              <a:buChar char="•"/>
+              <a:defRPr sz="2000" kern="1200">
+                <a:solidFill>
+                  <a:schemeClr val="tx1"/>
+                </a:solidFill>
+                <a:latin typeface="+mn-lt"/>
+                <a:ea typeface="+mn-ea"/>
+                <a:cs typeface="+mn-cs"/>
+              </a:defRPr>
+            </a:lvl3pPr>
+            <a:lvl4pPr marL="1600200" indent="-228600" algn="l" defTabSz="914400" rtl="0" eaLnBrk="1" latinLnBrk="1" hangingPunct="1">
+              <a:lnSpc>
+                <a:spcPct val="120000"/>
+              </a:lnSpc>
+              <a:spcBef>
+                <a:spcPts val="500"/>
+              </a:spcBef>
+              <a:buFont typeface="Arial" panose="020B0604020202020204" pitchFamily="34" charset="0"/>
+              <a:buChar char="•"/>
+              <a:defRPr sz="1800" kern="1200">
+                <a:solidFill>
+                  <a:schemeClr val="tx1"/>
+                </a:solidFill>
+                <a:latin typeface="+mn-lt"/>
+                <a:ea typeface="+mn-ea"/>
+                <a:cs typeface="+mn-cs"/>
+              </a:defRPr>
+            </a:lvl4pPr>
+            <a:lvl5pPr marL="2057400" indent="-228600" algn="l" defTabSz="914400" rtl="0" eaLnBrk="1" latinLnBrk="1" hangingPunct="1">
+              <a:lnSpc>
+                <a:spcPct val="120000"/>
+              </a:lnSpc>
+              <a:spcBef>
+                <a:spcPts val="500"/>
+              </a:spcBef>
+              <a:buFont typeface="Arial" panose="020B0604020202020204" pitchFamily="34" charset="0"/>
+              <a:buChar char="•"/>
+              <a:defRPr sz="1800" kern="1200">
+                <a:solidFill>
+                  <a:schemeClr val="tx1"/>
+                </a:solidFill>
+                <a:latin typeface="+mn-lt"/>
+                <a:ea typeface="+mn-ea"/>
+                <a:cs typeface="+mn-cs"/>
+              </a:defRPr>
+            </a:lvl5pPr>
+            <a:lvl6pPr marL="2514600" indent="-228600" algn="l" defTabSz="914400" rtl="0" eaLnBrk="1" latinLnBrk="1" hangingPunct="1">
+              <a:lnSpc>
+                <a:spcPct val="90000"/>
+              </a:lnSpc>
+              <a:spcBef>
+                <a:spcPts val="500"/>
+              </a:spcBef>
+              <a:buFont typeface="Arial" panose="020B0604020202020204" pitchFamily="34" charset="0"/>
+              <a:buChar char="•"/>
+              <a:defRPr sz="1800" kern="1200">
+                <a:solidFill>
+                  <a:schemeClr val="tx1"/>
+                </a:solidFill>
+                <a:latin typeface="+mn-lt"/>
+                <a:ea typeface="+mn-ea"/>
+                <a:cs typeface="+mn-cs"/>
+              </a:defRPr>
+            </a:lvl6pPr>
+            <a:lvl7pPr marL="2971800" indent="-228600" algn="l" defTabSz="914400" rtl="0" eaLnBrk="1" latinLnBrk="1" hangingPunct="1">
+              <a:lnSpc>
+                <a:spcPct val="90000"/>
+              </a:lnSpc>
+              <a:spcBef>
+                <a:spcPts val="500"/>
+              </a:spcBef>
+              <a:buFont typeface="Arial" panose="020B0604020202020204" pitchFamily="34" charset="0"/>
+              <a:buChar char="•"/>
+              <a:defRPr sz="1800" kern="1200">
+                <a:solidFill>
+                  <a:schemeClr val="tx1"/>
+                </a:solidFill>
+                <a:latin typeface="+mn-lt"/>
+                <a:ea typeface="+mn-ea"/>
+                <a:cs typeface="+mn-cs"/>
+              </a:defRPr>
+            </a:lvl7pPr>
+            <a:lvl8pPr marL="3429000" indent="-228600" algn="l" defTabSz="914400" rtl="0" eaLnBrk="1" latinLnBrk="1" hangingPunct="1">
+              <a:lnSpc>
+                <a:spcPct val="90000"/>
+              </a:lnSpc>
+              <a:spcBef>
+                <a:spcPts val="500"/>
+              </a:spcBef>
+              <a:buFont typeface="Arial" panose="020B0604020202020204" pitchFamily="34" charset="0"/>
+              <a:buChar char="•"/>
+              <a:defRPr sz="1800" kern="1200">
+                <a:solidFill>
+                  <a:schemeClr val="tx1"/>
+                </a:solidFill>
+                <a:latin typeface="+mn-lt"/>
+                <a:ea typeface="+mn-ea"/>
+                <a:cs typeface="+mn-cs"/>
+              </a:defRPr>
+            </a:lvl8pPr>
+            <a:lvl9pPr marL="3886200" indent="-228600" algn="l" defTabSz="914400" rtl="0" eaLnBrk="1" latinLnBrk="1" hangingPunct="1">
+              <a:lnSpc>
+                <a:spcPct val="90000"/>
+              </a:lnSpc>
+              <a:spcBef>
+                <a:spcPts val="500"/>
+              </a:spcBef>
+              <a:buFont typeface="Arial" panose="020B0604020202020204" pitchFamily="34" charset="0"/>
+              <a:buChar char="•"/>
+              <a:defRPr sz="1800" kern="1200">
+                <a:solidFill>
+                  <a:schemeClr val="tx1"/>
+                </a:solidFill>
+                <a:latin typeface="+mn-lt"/>
+                <a:ea typeface="+mn-ea"/>
+                <a:cs typeface="+mn-cs"/>
+              </a:defRPr>
+            </a:lvl9pPr>
+          </a:lstStyle>
+          <a:p>
+            <a:pPr marL="0" indent="0">
+              <a:buFont typeface="Arial" panose="020B0604020202020204" pitchFamily="34" charset="0"/>
+              <a:buNone/>
+            </a:pPr>
+            <a:r>
+              <a:rPr lang="en-US" altLang="ko-KR" sz="1800" b="1" dirty="0">
+                <a:solidFill>
+                  <a:schemeClr val="bg1">
+                    <a:lumMod val="50000"/>
+                  </a:schemeClr>
+                </a:solidFill>
+                <a:latin typeface="Pretendard Medium" panose="02000603000000020004" pitchFamily="50" charset="-127"/>
+                <a:ea typeface="Pretendard Medium" panose="02000603000000020004" pitchFamily="50" charset="-127"/>
+              </a:rPr>
+              <a:t>*</a:t>
+            </a:r>
+            <a:r>
+              <a:rPr lang="ko-KR" altLang="en-US" sz="1800" b="1" dirty="0">
+                <a:solidFill>
+                  <a:schemeClr val="bg1">
+                    <a:lumMod val="50000"/>
+                  </a:schemeClr>
+                </a:solidFill>
+                <a:latin typeface="Pretendard Medium" panose="02000603000000020004" pitchFamily="50" charset="-127"/>
+                <a:ea typeface="Pretendard Medium" panose="02000603000000020004" pitchFamily="50" charset="-127"/>
+              </a:rPr>
+              <a:t> 자식 컴포넌트</a:t>
+            </a:r>
+            <a:endParaRPr lang="en-US" altLang="ko-KR" sz="1800" b="1" dirty="0">
+              <a:solidFill>
+                <a:schemeClr val="bg1">
+                  <a:lumMod val="50000"/>
+                </a:schemeClr>
+              </a:solidFill>
+              <a:latin typeface="Pretendard Medium" panose="02000603000000020004" pitchFamily="50" charset="-127"/>
+              <a:ea typeface="Pretendard Medium" panose="02000603000000020004" pitchFamily="50" charset="-127"/>
+            </a:endParaRPr>
+          </a:p>
+        </p:txBody>
+      </p:sp>
       <p:pic>
         <p:nvPicPr>
-          <p:cNvPr id="12" name="그림 11">
+          <p:cNvPr id="11" name="그림 10">
             <a:extLst>
               <a:ext uri="{FF2B5EF4-FFF2-40B4-BE49-F238E27FC236}">
-                <a16:creationId xmlns:a16="http://schemas.microsoft.com/office/drawing/2014/main" id="{B7480FD1-3459-79EB-205E-E4E841B5916A}"/>
+                <a16:creationId xmlns:a16="http://schemas.microsoft.com/office/drawing/2014/main" id="{B0A86B98-BBFF-06A4-C560-FAFC2D8ACD99}"/>
               </a:ext>
             </a:extLst>
           </p:cNvPr>
@@ -32953,8 +33417,8 @@
         </p:blipFill>
         <p:spPr>
           <a:xfrm>
-            <a:off x="6360753" y="1999396"/>
-            <a:ext cx="5378737" cy="4238982"/>
+            <a:off x="769148" y="3745468"/>
+            <a:ext cx="10888595" cy="581106"/>
           </a:xfrm>
           <a:prstGeom prst="rect">
             <a:avLst/>
@@ -32975,8 +33439,8 @@
         </p:nvSpPr>
         <p:spPr>
           <a:xfrm>
-            <a:off x="6415812" y="4946570"/>
-            <a:ext cx="4351575" cy="1087030"/>
+            <a:off x="4637346" y="3790984"/>
+            <a:ext cx="6452900" cy="470623"/>
           </a:xfrm>
           <a:prstGeom prst="rect">
             <a:avLst/>
@@ -33016,470 +33480,6 @@
           </a:p>
         </p:txBody>
       </p:sp>
-      <p:sp>
-        <p:nvSpPr>
-          <p:cNvPr id="7" name="내용 개체 틀 2">
-            <a:extLst>
-              <a:ext uri="{FF2B5EF4-FFF2-40B4-BE49-F238E27FC236}">
-                <a16:creationId xmlns:a16="http://schemas.microsoft.com/office/drawing/2014/main" id="{24A70FDD-59B7-03AC-60AC-4AAEEEF9E093}"/>
-              </a:ext>
-            </a:extLst>
-          </p:cNvPr>
-          <p:cNvSpPr txBox="1">
-            <a:spLocks/>
-          </p:cNvSpPr>
-          <p:nvPr/>
-        </p:nvSpPr>
-        <p:spPr>
-          <a:xfrm>
-            <a:off x="283840" y="3180090"/>
-            <a:ext cx="3867614" cy="437819"/>
-          </a:xfrm>
-          <a:prstGeom prst="rect">
-            <a:avLst/>
-          </a:prstGeom>
-        </p:spPr>
-        <p:txBody>
-          <a:bodyPr vert="horz" lIns="91440" tIns="45720" rIns="91440" bIns="45720" rtlCol="0">
-            <a:normAutofit/>
-          </a:bodyPr>
-          <a:lstStyle>
-            <a:lvl1pPr marL="228600" indent="-228600" algn="l" defTabSz="914400" rtl="0" eaLnBrk="1" latinLnBrk="1" hangingPunct="1">
-              <a:lnSpc>
-                <a:spcPct val="120000"/>
-              </a:lnSpc>
-              <a:spcBef>
-                <a:spcPts val="1000"/>
-              </a:spcBef>
-              <a:buFont typeface="Arial" panose="020B0604020202020204" pitchFamily="34" charset="0"/>
-              <a:buChar char="•"/>
-              <a:defRPr sz="2800" kern="1200">
-                <a:solidFill>
-                  <a:schemeClr val="tx1"/>
-                </a:solidFill>
-                <a:latin typeface="+mn-lt"/>
-                <a:ea typeface="+mn-ea"/>
-                <a:cs typeface="+mn-cs"/>
-              </a:defRPr>
-            </a:lvl1pPr>
-            <a:lvl2pPr marL="685800" indent="-228600" algn="l" defTabSz="914400" rtl="0" eaLnBrk="1" latinLnBrk="1" hangingPunct="1">
-              <a:lnSpc>
-                <a:spcPct val="120000"/>
-              </a:lnSpc>
-              <a:spcBef>
-                <a:spcPts val="500"/>
-              </a:spcBef>
-              <a:buFont typeface="Arial" panose="020B0604020202020204" pitchFamily="34" charset="0"/>
-              <a:buChar char="•"/>
-              <a:defRPr sz="2400" kern="1200">
-                <a:solidFill>
-                  <a:schemeClr val="tx1"/>
-                </a:solidFill>
-                <a:latin typeface="+mn-lt"/>
-                <a:ea typeface="+mn-ea"/>
-                <a:cs typeface="+mn-cs"/>
-              </a:defRPr>
-            </a:lvl2pPr>
-            <a:lvl3pPr marL="1143000" indent="-228600" algn="l" defTabSz="914400" rtl="0" eaLnBrk="1" latinLnBrk="1" hangingPunct="1">
-              <a:lnSpc>
-                <a:spcPct val="120000"/>
-              </a:lnSpc>
-              <a:spcBef>
-                <a:spcPts val="500"/>
-              </a:spcBef>
-              <a:buFont typeface="Arial" panose="020B0604020202020204" pitchFamily="34" charset="0"/>
-              <a:buChar char="•"/>
-              <a:defRPr sz="2000" kern="1200">
-                <a:solidFill>
-                  <a:schemeClr val="tx1"/>
-                </a:solidFill>
-                <a:latin typeface="+mn-lt"/>
-                <a:ea typeface="+mn-ea"/>
-                <a:cs typeface="+mn-cs"/>
-              </a:defRPr>
-            </a:lvl3pPr>
-            <a:lvl4pPr marL="1600200" indent="-228600" algn="l" defTabSz="914400" rtl="0" eaLnBrk="1" latinLnBrk="1" hangingPunct="1">
-              <a:lnSpc>
-                <a:spcPct val="120000"/>
-              </a:lnSpc>
-              <a:spcBef>
-                <a:spcPts val="500"/>
-              </a:spcBef>
-              <a:buFont typeface="Arial" panose="020B0604020202020204" pitchFamily="34" charset="0"/>
-              <a:buChar char="•"/>
-              <a:defRPr sz="1800" kern="1200">
-                <a:solidFill>
-                  <a:schemeClr val="tx1"/>
-                </a:solidFill>
-                <a:latin typeface="+mn-lt"/>
-                <a:ea typeface="+mn-ea"/>
-                <a:cs typeface="+mn-cs"/>
-              </a:defRPr>
-            </a:lvl4pPr>
-            <a:lvl5pPr marL="2057400" indent="-228600" algn="l" defTabSz="914400" rtl="0" eaLnBrk="1" latinLnBrk="1" hangingPunct="1">
-              <a:lnSpc>
-                <a:spcPct val="120000"/>
-              </a:lnSpc>
-              <a:spcBef>
-                <a:spcPts val="500"/>
-              </a:spcBef>
-              <a:buFont typeface="Arial" panose="020B0604020202020204" pitchFamily="34" charset="0"/>
-              <a:buChar char="•"/>
-              <a:defRPr sz="1800" kern="1200">
-                <a:solidFill>
-                  <a:schemeClr val="tx1"/>
-                </a:solidFill>
-                <a:latin typeface="+mn-lt"/>
-                <a:ea typeface="+mn-ea"/>
-                <a:cs typeface="+mn-cs"/>
-              </a:defRPr>
-            </a:lvl5pPr>
-            <a:lvl6pPr marL="2514600" indent="-228600" algn="l" defTabSz="914400" rtl="0" eaLnBrk="1" latinLnBrk="1" hangingPunct="1">
-              <a:lnSpc>
-                <a:spcPct val="90000"/>
-              </a:lnSpc>
-              <a:spcBef>
-                <a:spcPts val="500"/>
-              </a:spcBef>
-              <a:buFont typeface="Arial" panose="020B0604020202020204" pitchFamily="34" charset="0"/>
-              <a:buChar char="•"/>
-              <a:defRPr sz="1800" kern="1200">
-                <a:solidFill>
-                  <a:schemeClr val="tx1"/>
-                </a:solidFill>
-                <a:latin typeface="+mn-lt"/>
-                <a:ea typeface="+mn-ea"/>
-                <a:cs typeface="+mn-cs"/>
-              </a:defRPr>
-            </a:lvl6pPr>
-            <a:lvl7pPr marL="2971800" indent="-228600" algn="l" defTabSz="914400" rtl="0" eaLnBrk="1" latinLnBrk="1" hangingPunct="1">
-              <a:lnSpc>
-                <a:spcPct val="90000"/>
-              </a:lnSpc>
-              <a:spcBef>
-                <a:spcPts val="500"/>
-              </a:spcBef>
-              <a:buFont typeface="Arial" panose="020B0604020202020204" pitchFamily="34" charset="0"/>
-              <a:buChar char="•"/>
-              <a:defRPr sz="1800" kern="1200">
-                <a:solidFill>
-                  <a:schemeClr val="tx1"/>
-                </a:solidFill>
-                <a:latin typeface="+mn-lt"/>
-                <a:ea typeface="+mn-ea"/>
-                <a:cs typeface="+mn-cs"/>
-              </a:defRPr>
-            </a:lvl7pPr>
-            <a:lvl8pPr marL="3429000" indent="-228600" algn="l" defTabSz="914400" rtl="0" eaLnBrk="1" latinLnBrk="1" hangingPunct="1">
-              <a:lnSpc>
-                <a:spcPct val="90000"/>
-              </a:lnSpc>
-              <a:spcBef>
-                <a:spcPts val="500"/>
-              </a:spcBef>
-              <a:buFont typeface="Arial" panose="020B0604020202020204" pitchFamily="34" charset="0"/>
-              <a:buChar char="•"/>
-              <a:defRPr sz="1800" kern="1200">
-                <a:solidFill>
-                  <a:schemeClr val="tx1"/>
-                </a:solidFill>
-                <a:latin typeface="+mn-lt"/>
-                <a:ea typeface="+mn-ea"/>
-                <a:cs typeface="+mn-cs"/>
-              </a:defRPr>
-            </a:lvl8pPr>
-            <a:lvl9pPr marL="3886200" indent="-228600" algn="l" defTabSz="914400" rtl="0" eaLnBrk="1" latinLnBrk="1" hangingPunct="1">
-              <a:lnSpc>
-                <a:spcPct val="90000"/>
-              </a:lnSpc>
-              <a:spcBef>
-                <a:spcPts val="500"/>
-              </a:spcBef>
-              <a:buFont typeface="Arial" panose="020B0604020202020204" pitchFamily="34" charset="0"/>
-              <a:buChar char="•"/>
-              <a:defRPr sz="1800" kern="1200">
-                <a:solidFill>
-                  <a:schemeClr val="tx1"/>
-                </a:solidFill>
-                <a:latin typeface="+mn-lt"/>
-                <a:ea typeface="+mn-ea"/>
-                <a:cs typeface="+mn-cs"/>
-              </a:defRPr>
-            </a:lvl9pPr>
-          </a:lstStyle>
-          <a:p>
-            <a:pPr marL="0" indent="0">
-              <a:buFont typeface="Arial" panose="020B0604020202020204" pitchFamily="34" charset="0"/>
-              <a:buNone/>
-            </a:pPr>
-            <a:r>
-              <a:rPr lang="en-US" altLang="ko-KR" sz="1800" b="1" dirty="0">
-                <a:solidFill>
-                  <a:schemeClr val="bg1">
-                    <a:lumMod val="50000"/>
-                  </a:schemeClr>
-                </a:solidFill>
-                <a:latin typeface="Pretendard Medium" panose="02000603000000020004" pitchFamily="50" charset="-127"/>
-                <a:ea typeface="Pretendard Medium" panose="02000603000000020004" pitchFamily="50" charset="-127"/>
-              </a:rPr>
-              <a:t>*</a:t>
-            </a:r>
-            <a:r>
-              <a:rPr lang="ko-KR" altLang="en-US" sz="1800" b="1" dirty="0">
-                <a:solidFill>
-                  <a:schemeClr val="bg1">
-                    <a:lumMod val="50000"/>
-                  </a:schemeClr>
-                </a:solidFill>
-                <a:latin typeface="Pretendard Medium" panose="02000603000000020004" pitchFamily="50" charset="-127"/>
-                <a:ea typeface="Pretendard Medium" panose="02000603000000020004" pitchFamily="50" charset="-127"/>
-              </a:rPr>
-              <a:t> 부모 컴포넌트</a:t>
-            </a:r>
-            <a:endParaRPr lang="en-US" altLang="ko-KR" sz="1800" b="1" dirty="0">
-              <a:solidFill>
-                <a:schemeClr val="bg1">
-                  <a:lumMod val="50000"/>
-                </a:schemeClr>
-              </a:solidFill>
-              <a:latin typeface="Pretendard Medium" panose="02000603000000020004" pitchFamily="50" charset="-127"/>
-              <a:ea typeface="Pretendard Medium" panose="02000603000000020004" pitchFamily="50" charset="-127"/>
-            </a:endParaRPr>
-          </a:p>
-        </p:txBody>
-      </p:sp>
-      <p:sp>
-        <p:nvSpPr>
-          <p:cNvPr id="9" name="내용 개체 틀 2">
-            <a:extLst>
-              <a:ext uri="{FF2B5EF4-FFF2-40B4-BE49-F238E27FC236}">
-                <a16:creationId xmlns:a16="http://schemas.microsoft.com/office/drawing/2014/main" id="{4FF724C0-6D72-23E7-5BB6-6E2A64B863CA}"/>
-              </a:ext>
-            </a:extLst>
-          </p:cNvPr>
-          <p:cNvSpPr txBox="1">
-            <a:spLocks/>
-          </p:cNvSpPr>
-          <p:nvPr/>
-        </p:nvSpPr>
-        <p:spPr>
-          <a:xfrm>
-            <a:off x="4737840" y="5800559"/>
-            <a:ext cx="3867614" cy="437819"/>
-          </a:xfrm>
-          <a:prstGeom prst="rect">
-            <a:avLst/>
-          </a:prstGeom>
-        </p:spPr>
-        <p:txBody>
-          <a:bodyPr vert="horz" lIns="91440" tIns="45720" rIns="91440" bIns="45720" rtlCol="0">
-            <a:normAutofit/>
-          </a:bodyPr>
-          <a:lstStyle>
-            <a:lvl1pPr marL="228600" indent="-228600" algn="l" defTabSz="914400" rtl="0" eaLnBrk="1" latinLnBrk="1" hangingPunct="1">
-              <a:lnSpc>
-                <a:spcPct val="120000"/>
-              </a:lnSpc>
-              <a:spcBef>
-                <a:spcPts val="1000"/>
-              </a:spcBef>
-              <a:buFont typeface="Arial" panose="020B0604020202020204" pitchFamily="34" charset="0"/>
-              <a:buChar char="•"/>
-              <a:defRPr sz="2800" kern="1200">
-                <a:solidFill>
-                  <a:schemeClr val="tx1"/>
-                </a:solidFill>
-                <a:latin typeface="+mn-lt"/>
-                <a:ea typeface="+mn-ea"/>
-                <a:cs typeface="+mn-cs"/>
-              </a:defRPr>
-            </a:lvl1pPr>
-            <a:lvl2pPr marL="685800" indent="-228600" algn="l" defTabSz="914400" rtl="0" eaLnBrk="1" latinLnBrk="1" hangingPunct="1">
-              <a:lnSpc>
-                <a:spcPct val="120000"/>
-              </a:lnSpc>
-              <a:spcBef>
-                <a:spcPts val="500"/>
-              </a:spcBef>
-              <a:buFont typeface="Arial" panose="020B0604020202020204" pitchFamily="34" charset="0"/>
-              <a:buChar char="•"/>
-              <a:defRPr sz="2400" kern="1200">
-                <a:solidFill>
-                  <a:schemeClr val="tx1"/>
-                </a:solidFill>
-                <a:latin typeface="+mn-lt"/>
-                <a:ea typeface="+mn-ea"/>
-                <a:cs typeface="+mn-cs"/>
-              </a:defRPr>
-            </a:lvl2pPr>
-            <a:lvl3pPr marL="1143000" indent="-228600" algn="l" defTabSz="914400" rtl="0" eaLnBrk="1" latinLnBrk="1" hangingPunct="1">
-              <a:lnSpc>
-                <a:spcPct val="120000"/>
-              </a:lnSpc>
-              <a:spcBef>
-                <a:spcPts val="500"/>
-              </a:spcBef>
-              <a:buFont typeface="Arial" panose="020B0604020202020204" pitchFamily="34" charset="0"/>
-              <a:buChar char="•"/>
-              <a:defRPr sz="2000" kern="1200">
-                <a:solidFill>
-                  <a:schemeClr val="tx1"/>
-                </a:solidFill>
-                <a:latin typeface="+mn-lt"/>
-                <a:ea typeface="+mn-ea"/>
-                <a:cs typeface="+mn-cs"/>
-              </a:defRPr>
-            </a:lvl3pPr>
-            <a:lvl4pPr marL="1600200" indent="-228600" algn="l" defTabSz="914400" rtl="0" eaLnBrk="1" latinLnBrk="1" hangingPunct="1">
-              <a:lnSpc>
-                <a:spcPct val="120000"/>
-              </a:lnSpc>
-              <a:spcBef>
-                <a:spcPts val="500"/>
-              </a:spcBef>
-              <a:buFont typeface="Arial" panose="020B0604020202020204" pitchFamily="34" charset="0"/>
-              <a:buChar char="•"/>
-              <a:defRPr sz="1800" kern="1200">
-                <a:solidFill>
-                  <a:schemeClr val="tx1"/>
-                </a:solidFill>
-                <a:latin typeface="+mn-lt"/>
-                <a:ea typeface="+mn-ea"/>
-                <a:cs typeface="+mn-cs"/>
-              </a:defRPr>
-            </a:lvl4pPr>
-            <a:lvl5pPr marL="2057400" indent="-228600" algn="l" defTabSz="914400" rtl="0" eaLnBrk="1" latinLnBrk="1" hangingPunct="1">
-              <a:lnSpc>
-                <a:spcPct val="120000"/>
-              </a:lnSpc>
-              <a:spcBef>
-                <a:spcPts val="500"/>
-              </a:spcBef>
-              <a:buFont typeface="Arial" panose="020B0604020202020204" pitchFamily="34" charset="0"/>
-              <a:buChar char="•"/>
-              <a:defRPr sz="1800" kern="1200">
-                <a:solidFill>
-                  <a:schemeClr val="tx1"/>
-                </a:solidFill>
-                <a:latin typeface="+mn-lt"/>
-                <a:ea typeface="+mn-ea"/>
-                <a:cs typeface="+mn-cs"/>
-              </a:defRPr>
-            </a:lvl5pPr>
-            <a:lvl6pPr marL="2514600" indent="-228600" algn="l" defTabSz="914400" rtl="0" eaLnBrk="1" latinLnBrk="1" hangingPunct="1">
-              <a:lnSpc>
-                <a:spcPct val="90000"/>
-              </a:lnSpc>
-              <a:spcBef>
-                <a:spcPts val="500"/>
-              </a:spcBef>
-              <a:buFont typeface="Arial" panose="020B0604020202020204" pitchFamily="34" charset="0"/>
-              <a:buChar char="•"/>
-              <a:defRPr sz="1800" kern="1200">
-                <a:solidFill>
-                  <a:schemeClr val="tx1"/>
-                </a:solidFill>
-                <a:latin typeface="+mn-lt"/>
-                <a:ea typeface="+mn-ea"/>
-                <a:cs typeface="+mn-cs"/>
-              </a:defRPr>
-            </a:lvl6pPr>
-            <a:lvl7pPr marL="2971800" indent="-228600" algn="l" defTabSz="914400" rtl="0" eaLnBrk="1" latinLnBrk="1" hangingPunct="1">
-              <a:lnSpc>
-                <a:spcPct val="90000"/>
-              </a:lnSpc>
-              <a:spcBef>
-                <a:spcPts val="500"/>
-              </a:spcBef>
-              <a:buFont typeface="Arial" panose="020B0604020202020204" pitchFamily="34" charset="0"/>
-              <a:buChar char="•"/>
-              <a:defRPr sz="1800" kern="1200">
-                <a:solidFill>
-                  <a:schemeClr val="tx1"/>
-                </a:solidFill>
-                <a:latin typeface="+mn-lt"/>
-                <a:ea typeface="+mn-ea"/>
-                <a:cs typeface="+mn-cs"/>
-              </a:defRPr>
-            </a:lvl7pPr>
-            <a:lvl8pPr marL="3429000" indent="-228600" algn="l" defTabSz="914400" rtl="0" eaLnBrk="1" latinLnBrk="1" hangingPunct="1">
-              <a:lnSpc>
-                <a:spcPct val="90000"/>
-              </a:lnSpc>
-              <a:spcBef>
-                <a:spcPts val="500"/>
-              </a:spcBef>
-              <a:buFont typeface="Arial" panose="020B0604020202020204" pitchFamily="34" charset="0"/>
-              <a:buChar char="•"/>
-              <a:defRPr sz="1800" kern="1200">
-                <a:solidFill>
-                  <a:schemeClr val="tx1"/>
-                </a:solidFill>
-                <a:latin typeface="+mn-lt"/>
-                <a:ea typeface="+mn-ea"/>
-                <a:cs typeface="+mn-cs"/>
-              </a:defRPr>
-            </a:lvl8pPr>
-            <a:lvl9pPr marL="3886200" indent="-228600" algn="l" defTabSz="914400" rtl="0" eaLnBrk="1" latinLnBrk="1" hangingPunct="1">
-              <a:lnSpc>
-                <a:spcPct val="90000"/>
-              </a:lnSpc>
-              <a:spcBef>
-                <a:spcPts val="500"/>
-              </a:spcBef>
-              <a:buFont typeface="Arial" panose="020B0604020202020204" pitchFamily="34" charset="0"/>
-              <a:buChar char="•"/>
-              <a:defRPr sz="1800" kern="1200">
-                <a:solidFill>
-                  <a:schemeClr val="tx1"/>
-                </a:solidFill>
-                <a:latin typeface="+mn-lt"/>
-                <a:ea typeface="+mn-ea"/>
-                <a:cs typeface="+mn-cs"/>
-              </a:defRPr>
-            </a:lvl9pPr>
-          </a:lstStyle>
-          <a:p>
-            <a:pPr marL="0" indent="0">
-              <a:buFont typeface="Arial" panose="020B0604020202020204" pitchFamily="34" charset="0"/>
-              <a:buNone/>
-            </a:pPr>
-            <a:r>
-              <a:rPr lang="en-US" altLang="ko-KR" sz="1800" b="1" dirty="0">
-                <a:solidFill>
-                  <a:schemeClr val="bg1">
-                    <a:lumMod val="50000"/>
-                  </a:schemeClr>
-                </a:solidFill>
-                <a:latin typeface="Pretendard Medium" panose="02000603000000020004" pitchFamily="50" charset="-127"/>
-                <a:ea typeface="Pretendard Medium" panose="02000603000000020004" pitchFamily="50" charset="-127"/>
-              </a:rPr>
-              <a:t>*</a:t>
-            </a:r>
-            <a:r>
-              <a:rPr lang="ko-KR" altLang="en-US" sz="1800" b="1" dirty="0">
-                <a:solidFill>
-                  <a:schemeClr val="bg1">
-                    <a:lumMod val="50000"/>
-                  </a:schemeClr>
-                </a:solidFill>
-                <a:latin typeface="Pretendard Medium" panose="02000603000000020004" pitchFamily="50" charset="-127"/>
-                <a:ea typeface="Pretendard Medium" panose="02000603000000020004" pitchFamily="50" charset="-127"/>
-              </a:rPr>
-              <a:t> 자식 컴포넌트</a:t>
-            </a:r>
-            <a:endParaRPr lang="en-US" altLang="ko-KR" sz="1800" b="1" dirty="0">
-              <a:solidFill>
-                <a:schemeClr val="bg1">
-                  <a:lumMod val="50000"/>
-                </a:schemeClr>
-              </a:solidFill>
-              <a:latin typeface="Pretendard Medium" panose="02000603000000020004" pitchFamily="50" charset="-127"/>
-              <a:ea typeface="Pretendard Medium" panose="02000603000000020004" pitchFamily="50" charset="-127"/>
-            </a:endParaRPr>
-          </a:p>
-        </p:txBody>
-      </p:sp>
     </p:spTree>
     <p:extLst>
       <p:ext uri="{BB962C8B-B14F-4D97-AF65-F5344CB8AC3E}">
@@ -33562,7 +33562,7 @@
           <a:p>
             <a:fld id="{EE8F6701-635E-4B4D-8246-F6CD3AE14CBE}" type="datetime6">
               <a:rPr lang="ko-KR" altLang="en-US" smtClean="0"/>
-              <a:t>2026년 1월</a:t>
+              <a:t>2026년 2월</a:t>
             </a:fld>
             <a:endParaRPr lang="ko-KR" altLang="en-US"/>
           </a:p>
@@ -34273,7 +34273,7 @@
 </file>
 
 <file path=ppt/slides/slide52.xml><?xml version="1.0" encoding="utf-8"?>
-<p:sld xmlns:a="http://schemas.openxmlformats.org/drawingml/2006/main" xmlns:r="http://schemas.openxmlformats.org/officeDocument/2006/relationships" xmlns:p="http://schemas.openxmlformats.org/presentationml/2006/main">
+<p:sld xmlns:a="http://schemas.openxmlformats.org/drawingml/2006/main" xmlns:r="http://schemas.openxmlformats.org/officeDocument/2006/relationships" xmlns:p="http://schemas.openxmlformats.org/presentationml/2006/main" show="0">
   <p:cSld>
     <p:spTree>
       <p:nvGrpSpPr>
@@ -34456,7 +34456,7 @@
           <a:p>
             <a:fld id="{87980AA1-5246-4A25-BE32-94BE467B109F}" type="datetime6">
               <a:rPr lang="ko-KR" altLang="en-US" smtClean="0"/>
-              <a:t>2026년 1월</a:t>
+              <a:t>2026년 2월</a:t>
             </a:fld>
             <a:endParaRPr lang="ko-KR" altLang="en-US"/>
           </a:p>
@@ -34610,7 +34610,7 @@
           <a:p>
             <a:fld id="{6E4A776D-1119-47AB-8A89-B6C229E43FDB}" type="datetime6">
               <a:rPr lang="ko-KR" altLang="en-US" smtClean="0"/>
-              <a:t>2026년 1월</a:t>
+              <a:t>2026년 2월</a:t>
             </a:fld>
             <a:endParaRPr lang="ko-KR" altLang="en-US"/>
           </a:p>
@@ -34764,7 +34764,7 @@
           <a:p>
             <a:fld id="{3CDE9A52-66EB-4C85-B703-18792A161207}" type="datetime6">
               <a:rPr lang="ko-KR" altLang="en-US" smtClean="0"/>
-              <a:t>2026년 1월</a:t>
+              <a:t>2026년 2월</a:t>
             </a:fld>
             <a:endParaRPr lang="ko-KR" altLang="en-US"/>
           </a:p>
@@ -35006,7 +35006,7 @@
           <a:p>
             <a:fld id="{3CDE9A52-66EB-4C85-B703-18792A161207}" type="datetime6">
               <a:rPr lang="ko-KR" altLang="en-US" smtClean="0"/>
-              <a:t>2026년 1월</a:t>
+              <a:t>2026년 2월</a:t>
             </a:fld>
             <a:endParaRPr lang="ko-KR" altLang="en-US"/>
           </a:p>
@@ -35373,7 +35373,7 @@
           <a:p>
             <a:fld id="{3C9CE3CE-253F-4F9D-BA15-C226C8D8501E}" type="datetime6">
               <a:rPr lang="ko-KR" altLang="en-US" smtClean="0"/>
-              <a:t>2026년 1월</a:t>
+              <a:t>2026년 2월</a:t>
             </a:fld>
             <a:endParaRPr lang="ko-KR" altLang="en-US"/>
           </a:p>
@@ -35519,7 +35519,7 @@
           <a:p>
             <a:fld id="{3C9CE3CE-253F-4F9D-BA15-C226C8D8501E}" type="datetime6">
               <a:rPr lang="ko-KR" altLang="en-US" smtClean="0"/>
-              <a:t>2026년 1월</a:t>
+              <a:t>2026년 2월</a:t>
             </a:fld>
             <a:endParaRPr lang="ko-KR" altLang="en-US"/>
           </a:p>
@@ -35674,7 +35674,7 @@
           <a:p>
             <a:fld id="{3C9CE3CE-253F-4F9D-BA15-C226C8D8501E}" type="datetime6">
               <a:rPr lang="ko-KR" altLang="en-US" smtClean="0"/>
-              <a:t>2026년 1월</a:t>
+              <a:t>2026년 2월</a:t>
             </a:fld>
             <a:endParaRPr lang="ko-KR" altLang="en-US"/>
           </a:p>
@@ -36969,7 +36969,7 @@
           <a:p>
             <a:fld id="{2C16E909-BEFD-4A9C-BB36-F9A91296299E}" type="datetime6">
               <a:rPr lang="ko-KR" altLang="en-US" smtClean="0"/>
-              <a:t>2026년 1월</a:t>
+              <a:t>2026년 2월</a:t>
             </a:fld>
             <a:endParaRPr lang="ko-KR" altLang="en-US"/>
           </a:p>
@@ -37237,7 +37237,7 @@
           <a:p>
             <a:fld id="{7D908F57-5581-4FA1-9B0C-81906BCA3B4F}" type="datetime6">
               <a:rPr lang="ko-KR" altLang="en-US" smtClean="0"/>
-              <a:t>2026년 1월</a:t>
+              <a:t>2026년 2월</a:t>
             </a:fld>
             <a:endParaRPr lang="ko-KR" altLang="en-US"/>
           </a:p>
@@ -37407,7 +37407,7 @@
           <a:p>
             <a:fld id="{18863825-48B7-4D15-9EE9-BC4A2FA13F72}" type="datetime6">
               <a:rPr lang="ko-KR" altLang="en-US" smtClean="0"/>
-              <a:t>2026년 1월</a:t>
+              <a:t>2026년 2월</a:t>
             </a:fld>
             <a:endParaRPr lang="ko-KR" altLang="en-US"/>
           </a:p>
@@ -37519,7 +37519,7 @@
           <a:p>
             <a:fld id="{0E19CB95-6D28-40F1-9DA3-1BAC5D4B5B4F}" type="datetime6">
               <a:rPr lang="ko-KR" altLang="en-US" smtClean="0"/>
-              <a:t>2026년 1월</a:t>
+              <a:t>2026년 2월</a:t>
             </a:fld>
             <a:endParaRPr lang="ko-KR" altLang="en-US"/>
           </a:p>
@@ -37718,7 +37718,7 @@
           <a:p>
             <a:fld id="{3C9CE3CE-253F-4F9D-BA15-C226C8D8501E}" type="datetime6">
               <a:rPr lang="ko-KR" altLang="en-US" smtClean="0"/>
-              <a:t>2026년 1월</a:t>
+              <a:t>2026년 2월</a:t>
             </a:fld>
             <a:endParaRPr lang="ko-KR" altLang="en-US"/>
           </a:p>

</xml_diff>